<commit_message>
A2 slides: plain-language traffic model slide, drop table references
- slide 4: replace clause numbers, distribution names and formula
  symbols with plain descriptions and concrete numbers
- slide 3: remove the Table 6.5.3.1-1 reference

Co-Authored-By: Claude Opus 5.5 <noreply@anthropic.com>
</commit_message>
<xml_diff>
--- a/assets/ppt/a2-M11402804-AhmadRifqi.pptx
+++ b/assets/ppt/a2-M11402804-AhmadRifqi.pptx
@@ -4445,7 +4445,7 @@
                 </a:solidFill>
                 <a:latin typeface="Segoe UI"/>
               </a:rPr>
-              <a:t> → fixed per Table 6.5.3.1-1.</a:t>
+              <a:t> → fixed to match the spec.</a:t>
             </a:r>
           </a:p>
           <a:p>
@@ -4665,7 +4665,7 @@
                 </a:solidFill>
                 <a:latin typeface="Consolas"/>
               </a:rPr>
-              <a:t>TR 26.926 → TR 38.838</a:t>
+              <a:t>3GPP TR 26.926</a:t>
             </a:r>
           </a:p>
         </p:txBody>
@@ -4707,7 +4707,7 @@
                 </a:solidFill>
                 <a:latin typeface="Segoe UI Semibold"/>
               </a:rPr>
-              <a:t>The 3GPP XR downlink video model</a:t>
+              <a:t>The 3GPP XR video traffic model</a:t>
             </a:r>
           </a:p>
         </p:txBody>
@@ -4774,7 +4774,7 @@
                 <a:spcPct val="114999"/>
               </a:lnSpc>
               <a:spcAft>
-                <a:spcPts val="900"/>
+                <a:spcPts val="1000"/>
               </a:spcAft>
             </a:pPr>
             <a:r>
@@ -4793,7 +4793,7 @@
                 </a:solidFill>
                 <a:latin typeface="Segoe UI"/>
               </a:rPr>
-              <a:t>§6.4: </a:t>
+              <a:t>Frames: </a:t>
             </a:r>
             <a:r>
               <a:rPr sz="1500" b="0" i="0">
@@ -4802,7 +4802,7 @@
                 </a:solidFill>
                 <a:latin typeface="Segoe UI"/>
               </a:rPr>
-              <a:t>60 fps at 30 or 45 Mbit/s.</a:t>
+              <a:t>the video sends one frame every 1/60 s (60 frames per second) at 30 or 45 Mbit/s.</a:t>
             </a:r>
           </a:p>
           <a:p>
@@ -4811,7 +4811,7 @@
                 <a:spcPct val="114999"/>
               </a:lnSpc>
               <a:spcAft>
-                <a:spcPts val="900"/>
+                <a:spcPts val="1000"/>
               </a:spcAft>
             </a:pPr>
             <a:r>
@@ -4830,7 +4830,7 @@
                 </a:solidFill>
                 <a:latin typeface="Segoe UI"/>
               </a:rPr>
-              <a:t>§6.5.3.1, Table 6.5.3.1-1: </a:t>
+              <a:t>Frame size: </a:t>
             </a:r>
             <a:r>
               <a:rPr sz="1500" b="0" i="0">
@@ -4839,7 +4839,7 @@
                 </a:solidFill>
                 <a:latin typeface="Segoe UI"/>
               </a:rPr>
-              <a:t>frame size is a truncated Gaussian — STD 10.5 %, Min 50 %, Max 150 % of the mean.</a:t>
+              <a:t>random, averaging 62 500 bytes — most within ±10 %, never below half or above 1.5× the average.</a:t>
             </a:r>
           </a:p>
           <a:p>
@@ -4848,7 +4848,7 @@
                 <a:spcPct val="114999"/>
               </a:lnSpc>
               <a:spcAft>
-                <a:spcPts val="900"/>
+                <a:spcPts val="1000"/>
               </a:spcAft>
             </a:pPr>
             <a:r>
@@ -4867,7 +4867,7 @@
                 </a:solidFill>
                 <a:latin typeface="Segoe UI"/>
               </a:rPr>
-              <a:t>§6.5.3.2: </a:t>
+              <a:t>Timing: </a:t>
             </a:r>
             <a:r>
               <a:rPr sz="1500" b="0" i="0">
@@ -4876,7 +4876,7 @@
                 </a:solidFill>
                 <a:latin typeface="Segoe UI"/>
               </a:rPr>
-              <a:t>jitter is a truncated Gaussian </a:t>
+              <a:t>each frame leaves near its fixed time slot, shifted by a small random amount of up to ±4 ms. The shifts </a:t>
             </a:r>
             <a:r>
               <a:rPr sz="1500" b="1" i="0">
@@ -4885,7 +4885,7 @@
                 </a:solidFill>
                 <a:latin typeface="Segoe UI"/>
               </a:rPr>
-              <a:t>added on top of periodic arrivals</a:t>
+              <a:t>do not add up</a:t>
             </a:r>
             <a:r>
               <a:rPr sz="1500" b="0" i="0">
@@ -4894,7 +4894,7 @@
                 </a:solidFill>
                 <a:latin typeface="Segoe UI"/>
               </a:rPr>
-              <a:t> (TR 38.838: mean 0, STD 2 ms, ±4 ms).</a:t>
+              <a:t> over time.</a:t>
             </a:r>
           </a:p>
           <a:p>
@@ -4903,7 +4903,7 @@
                 <a:spcPct val="114999"/>
               </a:lnSpc>
               <a:spcAft>
-                <a:spcPts val="900"/>
+                <a:spcPts val="1000"/>
               </a:spcAft>
             </a:pPr>
             <a:r>
@@ -4922,7 +4922,7 @@
                 </a:solidFill>
                 <a:latin typeface="Segoe UI"/>
               </a:rPr>
-              <a:t>§5.7.2: </a:t>
+              <a:t>Packets: </a:t>
             </a:r>
             <a:r>
               <a:rPr sz="1500" b="0" i="0">
@@ -4931,7 +4931,7 @@
                 </a:solidFill>
                 <a:latin typeface="Segoe UI"/>
               </a:rPr>
-              <a:t>each frame is fragmented into IP packets — here ≤ 1400 B UDP payload, ~45 packets per frame.</a:t>
+              <a:t>each frame is cut into packets of at most 1400 bytes — about 45 per frame.</a:t>
             </a:r>
           </a:p>
           <a:p>
@@ -4940,7 +4940,7 @@
                 <a:spcPct val="114999"/>
               </a:lnSpc>
               <a:spcAft>
-                <a:spcPts val="900"/>
+                <a:spcPts val="1000"/>
               </a:spcAft>
             </a:pPr>
             <a:r>
@@ -4959,7 +4959,7 @@
                 </a:solidFill>
                 <a:latin typeface="Segoe UI"/>
               </a:rPr>
-              <a:t>Delay budget: </a:t>
+              <a:t>Delay limit: </a:t>
             </a:r>
             <a:r>
               <a:rPr sz="1500" b="0" i="0">
@@ -4968,7 +4968,7 @@
                 </a:solidFill>
                 <a:latin typeface="Segoe UI"/>
               </a:rPr>
-              <a:t>10 ms per packet for VR.</a:t>
+              <a:t>every packet should arrive within 10 ms.</a:t>
             </a:r>
           </a:p>
         </p:txBody>
@@ -4982,7 +4982,7 @@
         <p:spPr>
           <a:xfrm>
             <a:off x="7315200" y="2331720"/>
-            <a:ext cx="4023360" cy="1691640"/>
+            <a:ext cx="4023360" cy="1828800"/>
           </a:xfrm>
           <a:prstGeom prst="roundRect">
             <a:avLst>
@@ -5029,8 +5029,8 @@
         </p:nvSpPr>
         <p:spPr>
           <a:xfrm>
-            <a:off x="7543800" y="2487168"/>
-            <a:ext cx="3566160" cy="1463040"/>
+            <a:off x="7589520" y="2514600"/>
+            <a:ext cx="3474720" cy="1554480"/>
           </a:xfrm>
           <a:prstGeom prst="rect">
             <a:avLst/>
@@ -5038,128 +5038,103 @@
           <a:noFill/>
         </p:spPr>
         <p:txBody>
-          <a:bodyPr wrap="square" anchor="ctr" lIns="0" rIns="0" tIns="0" bIns="0">
+          <a:bodyPr wrap="square" anchor="t" lIns="0" rIns="0" tIns="0" bIns="0">
             <a:spAutoFit/>
           </a:bodyPr>
           <a:lstStyle/>
           <a:p>
-            <a:pPr algn="ctr">
+            <a:pPr algn="l">
               <a:lnSpc>
                 <a:spcPct val="108000"/>
               </a:lnSpc>
               <a:spcAft>
+                <a:spcPts val="800"/>
+              </a:spcAft>
+            </a:pPr>
+            <a:r>
+              <a:rPr sz="950" b="1" i="0" spc="80">
+                <a:solidFill>
+                  <a:srgbClr val="2F63E6"/>
+                </a:solidFill>
+                <a:latin typeface="Consolas"/>
+              </a:rPr>
+              <a:t>ONE FRAME</a:t>
+            </a:r>
+          </a:p>
+          <a:p>
+            <a:pPr algn="l">
+              <a:lnSpc>
+                <a:spcPct val="100000"/>
+              </a:lnSpc>
+              <a:spcAft>
+                <a:spcPts val="0"/>
+              </a:spcAft>
+            </a:pPr>
+            <a:r>
+              <a:rPr sz="2600" b="1" i="0">
+                <a:solidFill>
+                  <a:srgbClr val="2F63E6"/>
+                </a:solidFill>
+                <a:latin typeface="Segoe UI Semibold"/>
+              </a:rPr>
+              <a:t>16.67 ms</a:t>
+            </a:r>
+          </a:p>
+          <a:p>
+            <a:pPr algn="l">
+              <a:lnSpc>
+                <a:spcPct val="110000"/>
+              </a:lnSpc>
+              <a:spcAft>
                 <a:spcPts val="1000"/>
               </a:spcAft>
             </a:pPr>
             <a:r>
-              <a:rPr sz="950" b="1" i="0" spc="80">
+              <a:rPr sz="1200" b="0" i="0">
+                <a:solidFill>
+                  <a:srgbClr val="586274"/>
+                </a:solidFill>
+                <a:latin typeface="Segoe UI"/>
+              </a:rPr>
+              <a:t>between frames (60 per second)</a:t>
+            </a:r>
+          </a:p>
+          <a:p>
+            <a:pPr algn="l">
+              <a:lnSpc>
+                <a:spcPct val="100000"/>
+              </a:lnSpc>
+              <a:spcAft>
+                <a:spcPts val="0"/>
+              </a:spcAft>
+            </a:pPr>
+            <a:r>
+              <a:rPr sz="2600" b="1" i="0">
                 <a:solidFill>
                   <a:srgbClr val="2F63E6"/>
                 </a:solidFill>
-                <a:latin typeface="Consolas"/>
-              </a:rPr>
-              <a:t>FRAME k OF THE MODEL</a:t>
-            </a:r>
-          </a:p>
-          <a:p>
-            <a:pPr algn="ctr">
-              <a:lnSpc>
-                <a:spcPct val="100000"/>
-              </a:lnSpc>
-              <a:spcAft>
-                <a:spcPts val="800"/>
-              </a:spcAft>
-            </a:pPr>
-            <a:r>
-              <a:rPr sz="1900" b="0" i="1">
-                <a:solidFill>
-                  <a:srgbClr val="141A24"/>
-                </a:solidFill>
-                <a:latin typeface="Segoe UI"/>
-              </a:rPr>
-              <a:t>t</a:t>
-            </a:r>
-            <a:r>
-              <a:rPr sz="1900" b="0" i="1" baseline="-25000">
-                <a:solidFill>
-                  <a:srgbClr val="141A24"/>
-                </a:solidFill>
-                <a:latin typeface="Segoe UI"/>
-              </a:rPr>
-              <a:t>k</a:t>
-            </a:r>
-            <a:r>
-              <a:rPr sz="1900" b="0" i="0">
-                <a:solidFill>
-                  <a:srgbClr val="141A24"/>
-                </a:solidFill>
-                <a:latin typeface="Segoe UI"/>
-              </a:rPr>
-              <a:t> = t</a:t>
-            </a:r>
-            <a:r>
-              <a:rPr sz="1900" b="0" i="0" baseline="-25000">
-                <a:solidFill>
-                  <a:srgbClr val="141A24"/>
-                </a:solidFill>
-                <a:latin typeface="Segoe UI"/>
-              </a:rPr>
-              <a:t>0</a:t>
-            </a:r>
-            <a:r>
-              <a:rPr sz="1900" b="0" i="0">
-                <a:solidFill>
-                  <a:srgbClr val="141A24"/>
-                </a:solidFill>
-                <a:latin typeface="Segoe UI"/>
-              </a:rPr>
-              <a:t> + k·T + J</a:t>
-            </a:r>
-            <a:r>
-              <a:rPr sz="1900" b="0" i="0" baseline="-25000">
-                <a:solidFill>
-                  <a:srgbClr val="141A24"/>
-                </a:solidFill>
-                <a:latin typeface="Segoe UI"/>
-              </a:rPr>
-              <a:t>k</a:t>
-            </a:r>
-          </a:p>
-          <a:p>
-            <a:pPr algn="ctr">
-              <a:lnSpc>
-                <a:spcPct val="100000"/>
+                <a:latin typeface="Segoe UI Semibold"/>
+              </a:rPr>
+              <a:t>≈ 62 500 B</a:t>
+            </a:r>
+          </a:p>
+          <a:p>
+            <a:pPr algn="l">
+              <a:lnSpc>
+                <a:spcPct val="110000"/>
               </a:lnSpc>
               <a:spcAft>
                 <a:spcPts val="0"/>
               </a:spcAft>
             </a:pPr>
             <a:r>
-              <a:rPr sz="1900" b="0" i="1">
-                <a:solidFill>
-                  <a:srgbClr val="141A24"/>
-                </a:solidFill>
-                <a:latin typeface="Segoe UI"/>
-              </a:rPr>
-              <a:t>S</a:t>
-            </a:r>
-            <a:r>
-              <a:rPr sz="1900" b="0" i="1" baseline="-25000">
-                <a:solidFill>
-                  <a:srgbClr val="141A24"/>
-                </a:solidFill>
-                <a:latin typeface="Segoe UI"/>
-              </a:rPr>
-              <a:t>k</a:t>
-            </a:r>
-            <a:r>
-              <a:rPr sz="1450" b="0" i="0">
-                <a:solidFill>
-                  <a:srgbClr val="141A24"/>
-                </a:solidFill>
-                <a:latin typeface="Segoe UI"/>
-              </a:rPr>
-              <a:t> ~ N(M, 0.105M) in [0.5M, 1.5M]</a:t>
+              <a:rPr sz="1200" b="0" i="0">
+                <a:solidFill>
+                  <a:srgbClr val="586274"/>
+                </a:solidFill>
+                <a:latin typeface="Segoe UI"/>
+              </a:rPr>
+              <a:t>per frame, from 31 250 to 93 750 B</a:t>
             </a:r>
           </a:p>
         </p:txBody>
@@ -5172,8 +5147,8 @@
         </p:nvSpPr>
         <p:spPr>
           <a:xfrm>
-            <a:off x="7315200" y="4251960"/>
-            <a:ext cx="4023360" cy="1737360"/>
+            <a:off x="7315200" y="4389120"/>
+            <a:ext cx="4023360" cy="1600200"/>
           </a:xfrm>
           <a:prstGeom prst="roundRect">
             <a:avLst>
@@ -5220,8 +5195,8 @@
         </p:nvSpPr>
         <p:spPr>
           <a:xfrm>
-            <a:off x="7543800" y="4416552"/>
-            <a:ext cx="3566160" cy="1463039"/>
+            <a:off x="7543800" y="4553712"/>
+            <a:ext cx="3566160" cy="1325880"/>
           </a:xfrm>
           <a:prstGeom prst="rect">
             <a:avLst/>
@@ -5249,7 +5224,7 @@
                 </a:solidFill>
                 <a:latin typeface="Consolas"/>
               </a:rPr>
-              <a:t>WHAT EACH SYMBOL MEANS</a:t>
+              <a:t>AT 30 MBIT/S</a:t>
             </a:r>
           </a:p>
           <a:p>
@@ -5268,7 +5243,7 @@
                 </a:solidFill>
                 <a:latin typeface="Consolas"/>
               </a:rPr>
-              <a:t>T     </a:t>
+              <a:t>Shift     </a:t>
             </a:r>
             <a:r>
               <a:rPr sz="1200" b="0" i="0">
@@ -5277,7 +5252,7 @@
                 </a:solidFill>
                 <a:latin typeface="Segoe UI"/>
               </a:rPr>
-              <a:t>frame period = 1/60 s = 16.67 ms</a:t>
+              <a:t>random, up to ±4 ms per frame</a:t>
             </a:r>
           </a:p>
           <a:p>
@@ -5296,7 +5271,7 @@
                 </a:solidFill>
                 <a:latin typeface="Consolas"/>
               </a:rPr>
-              <a:t>Jₖ    </a:t>
+              <a:t>Packets   </a:t>
             </a:r>
             <a:r>
               <a:rPr sz="1200" b="0" i="0">
@@ -5305,7 +5280,7 @@
                 </a:solidFill>
                 <a:latin typeface="Segoe UI"/>
               </a:rPr>
-              <a:t>jitter, N(0, 2 ms) cut at ±4 ms</a:t>
+              <a:t>≤ 1400 B each, ~45 per frame</a:t>
             </a:r>
           </a:p>
           <a:p>
@@ -5324,7 +5299,7 @@
                 </a:solidFill>
                 <a:latin typeface="Consolas"/>
               </a:rPr>
-              <a:t>Sₖ    </a:t>
+              <a:t>Delay     </a:t>
             </a:r>
             <a:r>
               <a:rPr sz="1200" b="0" i="0">
@@ -5333,35 +5308,7 @@
                 </a:solidFill>
                 <a:latin typeface="Segoe UI"/>
               </a:rPr>
-              <a:t>size of frame k</a:t>
-            </a:r>
-          </a:p>
-          <a:p>
-            <a:pPr algn="l">
-              <a:lnSpc>
-                <a:spcPct val="105000"/>
-              </a:lnSpc>
-              <a:spcAft>
-                <a:spcPts val="500"/>
-              </a:spcAft>
-            </a:pPr>
-            <a:r>
-              <a:rPr sz="1250" b="1" i="0">
-                <a:solidFill>
-                  <a:srgbClr val="2F63E6"/>
-                </a:solidFill>
-                <a:latin typeface="Consolas"/>
-              </a:rPr>
-              <a:t>M     </a:t>
-            </a:r>
-            <a:r>
-              <a:rPr sz="1200" b="0" i="0">
-                <a:solidFill>
-                  <a:srgbClr val="586274"/>
-                </a:solidFill>
-                <a:latin typeface="Segoe UI"/>
-              </a:rPr>
-              <a:t>R / (8·F) = 62 500 B at 30 Mbit/s</a:t>
+              <a:t>at most 10 ms per packet</a:t>
             </a:r>
           </a:p>
         </p:txBody>

</xml_diff>